<commit_message>
docs: add sponsor integration architecture slide to explainer deck
</commit_message>
<xml_diff>
--- a/outputs/evox-simple-explainer.pptx
+++ b/outputs/evox-simple-explainer.pptx
@@ -13,6 +13,7 @@
     <p:sldId xmlns:r="http://schemas.openxmlformats.org/officeDocument/2006/relationships" id="258" r:id="R74a209f29d8d44d9"/>
     <p:sldId xmlns:r="http://schemas.openxmlformats.org/officeDocument/2006/relationships" id="259" r:id="R85aa0a7e44684d6b"/>
     <p:sldId xmlns:r="http://schemas.openxmlformats.org/officeDocument/2006/relationships" id="260" r:id="R0748647d19bf4972"/>
+    <p:sldId xmlns:ns0="http://schemas.openxmlformats.org/officeDocument/2006/relationships" id="261" ns0:id="rId11"/>
   </p:sldIdLst>
   <p:sldSz cx="12192000" cy="6858000"/>
   <p:notesSz cx="6858000" cy="9144000"/>
@@ -897,6 +898,101 @@
   </p:cSld>
   <p:clrMapOvr>
     <a:masterClrMapping xmlns:a="http://schemas.openxmlformats.org/drawingml/2006/main"/>
+  </p:clrMapOvr>
+</p:notes>
+</file>
+
+<file path=ppt/notesSlides/notesSlide6.xml><?xml version="1.0" encoding="utf-8"?>
+<p:notes xmlns:a="http://schemas.openxmlformats.org/drawingml/2006/main" xmlns:p="http://schemas.openxmlformats.org/presentationml/2006/main" xmlns:r="http://schemas.openxmlformats.org/officeDocument/2006/relationships">
+  <p:cSld>
+    <p:spTree>
+      <p:nvGrpSpPr>
+        <p:cNvPr id="1" name=""/>
+        <p:cNvGrpSpPr/>
+        <p:nvPr/>
+      </p:nvGrpSpPr>
+      <p:grpSpPr>
+        <a:xfrm>
+          <a:off x="0" y="0"/>
+          <a:ext cx="0" cy="0"/>
+          <a:chOff x="0" y="0"/>
+          <a:chExt cx="0" cy="0"/>
+        </a:xfrm>
+      </p:grpSpPr>
+      <p:sp>
+        <p:nvSpPr>
+          <p:cNvPr id="2" name="Slide Image Placeholder 1"/>
+          <p:cNvSpPr>
+            <a:spLocks noGrp="1"/>
+          </p:cNvSpPr>
+          <p:nvPr>
+            <p:ph type="sldImg" idx="2"/>
+          </p:nvPr>
+        </p:nvSpPr>
+        <p:spPr/>
+      </p:sp>
+      <p:sp>
+        <p:nvSpPr>
+          <p:cNvPr id="3" name="Notes Placeholder 2"/>
+          <p:cNvSpPr>
+            <a:spLocks noGrp="1"/>
+          </p:cNvSpPr>
+          <p:nvPr>
+            <p:ph type="body" idx="3" sz="quarter"/>
+          </p:nvPr>
+        </p:nvSpPr>
+        <p:spPr/>
+        <p:txBody>
+          <a:bodyPr/>
+          <a:lstStyle/>
+          <a:p>
+            <a:r>
+              <a:t>Sponsor Integration Architecture:</a:t>
+            </a:r>
+          </a:p>
+          <a:p>
+            <a:r>
+              <a:t>- Pioneer handles model execution fail-closed behind a clean gateway.</a:t>
+            </a:r>
+          </a:p>
+          <a:p>
+            <a:r>
+              <a:t>- Senso provides indexed documentation and cited context retrieval.</a:t>
+            </a:r>
+          </a:p>
+          <a:p>
+            <a:r>
+              <a:t>- Actian VectorAI stores execution trajectories and failure patterns for fast similarity search.</a:t>
+            </a:r>
+          </a:p>
+          <a:p>
+            <a:r>
+              <a:t>- Band routes uncertain decisions to real human reviewers.</a:t>
+            </a:r>
+          </a:p>
+          <a:p>
+            <a:r>
+              <a:t>- Guild.ai governs active release promotion and system publication.</a:t>
+            </a:r>
+          </a:p>
+        </p:txBody>
+      </p:sp>
+      <p:sp>
+        <p:nvSpPr>
+          <p:cNvPr id="4" name="Slide Number Placeholder 3"/>
+          <p:cNvSpPr>
+            <a:spLocks noGrp="1"/>
+          </p:cNvSpPr>
+          <p:nvPr>
+            <p:ph type="sldNum" idx="5" sz="quarter"/>
+          </p:nvPr>
+        </p:nvSpPr>
+        <p:spPr/>
+      </p:sp>
+    </p:spTree>
+  </p:cSld>
+  <p:clrMapOvr>
+    <a:masterClrMapping/>
   </p:clrMapOvr>
 </p:notes>
 </file>
@@ -6706,6 +6802,733 @@
 </p:sld>
 </file>
 
+<file path=ppt/slides/slide6.xml><?xml version="1.0" encoding="utf-8"?>
+<p:sld xmlns:a="http://schemas.openxmlformats.org/drawingml/2006/main" xmlns:p="http://schemas.openxmlformats.org/presentationml/2006/main" xmlns:r="http://schemas.openxmlformats.org/officeDocument/2006/relationships">
+  <p:cSld>
+    <p:spTree>
+      <p:nvGrpSpPr>
+        <p:cNvPr id="1" name=""/>
+        <p:cNvGrpSpPr/>
+        <p:nvPr/>
+      </p:nvGrpSpPr>
+      <p:grpSpPr/>
+      <p:sp>
+        <p:nvSpPr>
+          <p:cNvPr id="2" name="TextBox 1"/>
+          <p:cNvSpPr txBox="1"/>
+          <p:nvPr/>
+        </p:nvSpPr>
+        <p:spPr>
+          <a:xfrm>
+            <a:off x="685800" y="365760"/>
+            <a:ext cx="10817352" cy="365760"/>
+          </a:xfrm>
+          <a:prstGeom prst="rect">
+            <a:avLst/>
+          </a:prstGeom>
+          <a:noFill/>
+        </p:spPr>
+        <p:txBody>
+          <a:bodyPr wrap="none">
+            <a:spAutoFit/>
+          </a:bodyPr>
+          <a:lstStyle/>
+          <a:p>
+            <a:pPr>
+              <a:defRPr sz="1200" b="1">
+                <a:solidFill>
+                  <a:srgbClr val="0F172A"/>
+                </a:solidFill>
+                <a:latin typeface="Aptos"/>
+              </a:defRPr>
+            </a:pPr>
+            <a:r>
+              <a:t>EVOX</a:t>
+            </a:r>
+          </a:p>
+        </p:txBody>
+      </p:sp>
+      <p:sp>
+        <p:nvSpPr>
+          <p:cNvPr id="3" name="TextBox 2"/>
+          <p:cNvSpPr txBox="1"/>
+          <p:nvPr/>
+        </p:nvSpPr>
+        <p:spPr>
+          <a:xfrm>
+            <a:off x="9674352" y="365760"/>
+            <a:ext cx="1828800" cy="365760"/>
+          </a:xfrm>
+          <a:prstGeom prst="rect">
+            <a:avLst/>
+          </a:prstGeom>
+          <a:noFill/>
+        </p:spPr>
+        <p:txBody>
+          <a:bodyPr wrap="none">
+            <a:spAutoFit/>
+          </a:bodyPr>
+          <a:lstStyle/>
+          <a:p>
+            <a:pPr algn="r">
+              <a:defRPr sz="1200" b="1">
+                <a:solidFill>
+                  <a:srgbClr val="475569"/>
+                </a:solidFill>
+                <a:latin typeface="Aptos"/>
+              </a:defRPr>
+            </a:pPr>
+            <a:r>
+              <a:t>06 / 06</a:t>
+            </a:r>
+          </a:p>
+        </p:txBody>
+      </p:sp>
+      <p:sp>
+        <p:nvSpPr>
+          <p:cNvPr id="4" name="TextBox 3"/>
+          <p:cNvSpPr txBox="1"/>
+          <p:nvPr/>
+        </p:nvSpPr>
+        <p:spPr>
+          <a:xfrm>
+            <a:off x="685800" y="777240"/>
+            <a:ext cx="10817352" cy="548640"/>
+          </a:xfrm>
+          <a:prstGeom prst="rect">
+            <a:avLst/>
+          </a:prstGeom>
+          <a:noFill/>
+        </p:spPr>
+        <p:txBody>
+          <a:bodyPr wrap="square">
+            <a:spAutoFit/>
+          </a:bodyPr>
+          <a:lstStyle/>
+          <a:p>
+            <a:pPr>
+              <a:defRPr sz="2400" b="1">
+                <a:solidFill>
+                  <a:srgbClr val="0F172A"/>
+                </a:solidFill>
+                <a:latin typeface="Aptos"/>
+              </a:defRPr>
+            </a:pPr>
+            <a:r>
+              <a:t>Every sponsor technology sits behind a production port.</a:t>
+            </a:r>
+          </a:p>
+        </p:txBody>
+      </p:sp>
+      <p:sp>
+        <p:nvSpPr>
+          <p:cNvPr id="5" name="TextBox 4"/>
+          <p:cNvSpPr txBox="1"/>
+          <p:nvPr/>
+        </p:nvSpPr>
+        <p:spPr>
+          <a:xfrm>
+            <a:off x="685800" y="1325880"/>
+            <a:ext cx="10817352" cy="457200"/>
+          </a:xfrm>
+          <a:prstGeom prst="rect">
+            <a:avLst/>
+          </a:prstGeom>
+          <a:noFill/>
+        </p:spPr>
+        <p:txBody>
+          <a:bodyPr wrap="square">
+            <a:spAutoFit/>
+          </a:bodyPr>
+          <a:lstStyle/>
+          <a:p>
+            <a:pPr>
+              <a:defRPr sz="1400">
+                <a:solidFill>
+                  <a:srgbClr val="475569"/>
+                </a:solidFill>
+                <a:latin typeface="Aptos"/>
+              </a:defRPr>
+            </a:pPr>
+            <a:r>
+              <a:t>Real persisted state and configured integrations power the entire learning loop.</a:t>
+            </a:r>
+          </a:p>
+        </p:txBody>
+      </p:sp>
+      <p:sp>
+        <p:nvSpPr>
+          <p:cNvPr id="6" name="Rounded Rectangle 5"/>
+          <p:cNvSpPr/>
+          <p:nvPr/>
+        </p:nvSpPr>
+        <p:spPr>
+          <a:xfrm>
+            <a:off x="685800" y="1920240"/>
+            <a:ext cx="2011680" cy="3840480"/>
+          </a:xfrm>
+          <a:prstGeom prst="roundRect">
+            <a:avLst/>
+          </a:prstGeom>
+          <a:solidFill>
+            <a:srgbClr val="F8FAFC"/>
+          </a:solidFill>
+          <a:ln w="19050">
+            <a:solidFill>
+              <a:srgbClr val="2563EB"/>
+            </a:solidFill>
+          </a:ln>
+        </p:spPr>
+        <p:style>
+          <a:lnRef idx="1">
+            <a:schemeClr val="accent1"/>
+          </a:lnRef>
+          <a:fillRef idx="3">
+            <a:schemeClr val="accent1"/>
+          </a:fillRef>
+          <a:effectRef idx="2">
+            <a:schemeClr val="accent1"/>
+          </a:effectRef>
+          <a:fontRef idx="minor">
+            <a:schemeClr val="lt1"/>
+          </a:fontRef>
+        </p:style>
+        <p:txBody>
+          <a:bodyPr rtlCol="0" anchor="ctr"/>
+          <a:lstStyle/>
+          <a:p>
+            <a:pPr algn="ctr"/>
+          </a:p>
+        </p:txBody>
+      </p:sp>
+      <p:sp>
+        <p:nvSpPr>
+          <p:cNvPr id="7" name="TextBox 6"/>
+          <p:cNvSpPr txBox="1"/>
+          <p:nvPr/>
+        </p:nvSpPr>
+        <p:spPr>
+          <a:xfrm>
+            <a:off x="795528" y="2057400"/>
+            <a:ext cx="1792224" cy="3566160"/>
+          </a:xfrm>
+          <a:prstGeom prst="rect">
+            <a:avLst/>
+          </a:prstGeom>
+          <a:noFill/>
+        </p:spPr>
+        <p:txBody>
+          <a:bodyPr wrap="square">
+            <a:spAutoFit/>
+          </a:bodyPr>
+          <a:lstStyle/>
+          <a:p>
+            <a:pPr>
+              <a:spcAft>
+                <a:spcPts val="400"/>
+              </a:spcAft>
+              <a:defRPr sz="1300" b="1">
+                <a:solidFill>
+                  <a:srgbClr val="2563EB"/>
+                </a:solidFill>
+                <a:latin typeface="Aptos"/>
+              </a:defRPr>
+            </a:pPr>
+            <a:r>
+              <a:t>PIONEER</a:t>
+            </a:r>
+          </a:p>
+          <a:p>
+            <a:pPr>
+              <a:spcAft>
+                <a:spcPts val="1200"/>
+              </a:spcAft>
+              <a:defRPr sz="1100" b="1">
+                <a:solidFill>
+                  <a:srgbClr val="0F172A"/>
+                </a:solidFill>
+                <a:latin typeface="Aptos"/>
+              </a:defRPr>
+            </a:pPr>
+            <a:r>
+              <a:t>Model Gateway</a:t>
+            </a:r>
+          </a:p>
+          <a:p>
+            <a:pPr>
+              <a:defRPr sz="1050">
+                <a:solidFill>
+                  <a:srgbClr val="475569"/>
+                </a:solidFill>
+                <a:latin typeface="Aptos"/>
+              </a:defRPr>
+            </a:pPr>
+            <a:r>
+              <a:t>Production gateway for model execution and prompt inference.</a:t>
+            </a:r>
+          </a:p>
+        </p:txBody>
+      </p:sp>
+      <p:sp>
+        <p:nvSpPr>
+          <p:cNvPr id="8" name="Rounded Rectangle 7"/>
+          <p:cNvSpPr/>
+          <p:nvPr/>
+        </p:nvSpPr>
+        <p:spPr>
+          <a:xfrm>
+            <a:off x="2880360" y="1920240"/>
+            <a:ext cx="2011680" cy="3840480"/>
+          </a:xfrm>
+          <a:prstGeom prst="roundRect">
+            <a:avLst/>
+          </a:prstGeom>
+          <a:solidFill>
+            <a:srgbClr val="F8FAFC"/>
+          </a:solidFill>
+          <a:ln w="19050">
+            <a:solidFill>
+              <a:srgbClr val="9333EA"/>
+            </a:solidFill>
+          </a:ln>
+        </p:spPr>
+        <p:style>
+          <a:lnRef idx="1">
+            <a:schemeClr val="accent1"/>
+          </a:lnRef>
+          <a:fillRef idx="3">
+            <a:schemeClr val="accent1"/>
+          </a:fillRef>
+          <a:effectRef idx="2">
+            <a:schemeClr val="accent1"/>
+          </a:effectRef>
+          <a:fontRef idx="minor">
+            <a:schemeClr val="lt1"/>
+          </a:fontRef>
+        </p:style>
+        <p:txBody>
+          <a:bodyPr rtlCol="0" anchor="ctr"/>
+          <a:lstStyle/>
+          <a:p>
+            <a:pPr algn="ctr"/>
+          </a:p>
+        </p:txBody>
+      </p:sp>
+      <p:sp>
+        <p:nvSpPr>
+          <p:cNvPr id="9" name="TextBox 8"/>
+          <p:cNvSpPr txBox="1"/>
+          <p:nvPr/>
+        </p:nvSpPr>
+        <p:spPr>
+          <a:xfrm>
+            <a:off x="2990088" y="2057400"/>
+            <a:ext cx="1792224" cy="3566160"/>
+          </a:xfrm>
+          <a:prstGeom prst="rect">
+            <a:avLst/>
+          </a:prstGeom>
+          <a:noFill/>
+        </p:spPr>
+        <p:txBody>
+          <a:bodyPr wrap="square">
+            <a:spAutoFit/>
+          </a:bodyPr>
+          <a:lstStyle/>
+          <a:p>
+            <a:pPr>
+              <a:spcAft>
+                <a:spcPts val="400"/>
+              </a:spcAft>
+              <a:defRPr sz="1300" b="1">
+                <a:solidFill>
+                  <a:srgbClr val="9333EA"/>
+                </a:solidFill>
+                <a:latin typeface="Aptos"/>
+              </a:defRPr>
+            </a:pPr>
+            <a:r>
+              <a:t>SENSO</a:t>
+            </a:r>
+          </a:p>
+          <a:p>
+            <a:pPr>
+              <a:spcAft>
+                <a:spcPts val="1200"/>
+              </a:spcAft>
+              <a:defRPr sz="1100" b="1">
+                <a:solidFill>
+                  <a:srgbClr val="0F172A"/>
+                </a:solidFill>
+                <a:latin typeface="Aptos"/>
+              </a:defRPr>
+            </a:pPr>
+            <a:r>
+              <a:t>Knowledge Layer</a:t>
+            </a:r>
+          </a:p>
+          <a:p>
+            <a:pPr>
+              <a:defRPr sz="1050">
+                <a:solidFill>
+                  <a:srgbClr val="475569"/>
+                </a:solidFill>
+                <a:latin typeface="Aptos"/>
+              </a:defRPr>
+            </a:pPr>
+            <a:r>
+              <a:t>Ingests documentation and provides cited context retrieval.</a:t>
+            </a:r>
+          </a:p>
+        </p:txBody>
+      </p:sp>
+      <p:sp>
+        <p:nvSpPr>
+          <p:cNvPr id="10" name="Rounded Rectangle 9"/>
+          <p:cNvSpPr/>
+          <p:nvPr/>
+        </p:nvSpPr>
+        <p:spPr>
+          <a:xfrm>
+            <a:off x="5074920" y="1920240"/>
+            <a:ext cx="2011680" cy="3840480"/>
+          </a:xfrm>
+          <a:prstGeom prst="roundRect">
+            <a:avLst/>
+          </a:prstGeom>
+          <a:solidFill>
+            <a:srgbClr val="F8FAFC"/>
+          </a:solidFill>
+          <a:ln w="19050">
+            <a:solidFill>
+              <a:srgbClr val="16A34A"/>
+            </a:solidFill>
+          </a:ln>
+        </p:spPr>
+        <p:style>
+          <a:lnRef idx="1">
+            <a:schemeClr val="accent1"/>
+          </a:lnRef>
+          <a:fillRef idx="3">
+            <a:schemeClr val="accent1"/>
+          </a:fillRef>
+          <a:effectRef idx="2">
+            <a:schemeClr val="accent1"/>
+          </a:effectRef>
+          <a:fontRef idx="minor">
+            <a:schemeClr val="lt1"/>
+          </a:fontRef>
+        </p:style>
+        <p:txBody>
+          <a:bodyPr rtlCol="0" anchor="ctr"/>
+          <a:lstStyle/>
+          <a:p>
+            <a:pPr algn="ctr"/>
+          </a:p>
+        </p:txBody>
+      </p:sp>
+      <p:sp>
+        <p:nvSpPr>
+          <p:cNvPr id="11" name="TextBox 10"/>
+          <p:cNvSpPr txBox="1"/>
+          <p:nvPr/>
+        </p:nvSpPr>
+        <p:spPr>
+          <a:xfrm>
+            <a:off x="5184648" y="2057400"/>
+            <a:ext cx="1792224" cy="3566160"/>
+          </a:xfrm>
+          <a:prstGeom prst="rect">
+            <a:avLst/>
+          </a:prstGeom>
+          <a:noFill/>
+        </p:spPr>
+        <p:txBody>
+          <a:bodyPr wrap="square">
+            <a:spAutoFit/>
+          </a:bodyPr>
+          <a:lstStyle/>
+          <a:p>
+            <a:pPr>
+              <a:spcAft>
+                <a:spcPts val="400"/>
+              </a:spcAft>
+              <a:defRPr sz="1300" b="1">
+                <a:solidFill>
+                  <a:srgbClr val="16A34A"/>
+                </a:solidFill>
+                <a:latin typeface="Aptos"/>
+              </a:defRPr>
+            </a:pPr>
+            <a:r>
+              <a:t>ACTIAN VECTORAI</a:t>
+            </a:r>
+          </a:p>
+          <a:p>
+            <a:pPr>
+              <a:spcAft>
+                <a:spcPts val="1200"/>
+              </a:spcAft>
+              <a:defRPr sz="1100" b="1">
+                <a:solidFill>
+                  <a:srgbClr val="0F172A"/>
+                </a:solidFill>
+                <a:latin typeface="Aptos"/>
+              </a:defRPr>
+            </a:pPr>
+            <a:r>
+              <a:t>Outcome Memory</a:t>
+            </a:r>
+          </a:p>
+          <a:p>
+            <a:pPr>
+              <a:defRPr sz="1050">
+                <a:solidFill>
+                  <a:srgbClr val="475569"/>
+                </a:solidFill>
+                <a:latin typeface="Aptos"/>
+              </a:defRPr>
+            </a:pPr>
+            <a:r>
+              <a:t>Stores searchable run outcomes, trajectories, and failure patterns.</a:t>
+            </a:r>
+          </a:p>
+        </p:txBody>
+      </p:sp>
+      <p:sp>
+        <p:nvSpPr>
+          <p:cNvPr id="12" name="Rounded Rectangle 11"/>
+          <p:cNvSpPr/>
+          <p:nvPr/>
+        </p:nvSpPr>
+        <p:spPr>
+          <a:xfrm>
+            <a:off x="7269480" y="1920240"/>
+            <a:ext cx="2011680" cy="3840480"/>
+          </a:xfrm>
+          <a:prstGeom prst="roundRect">
+            <a:avLst/>
+          </a:prstGeom>
+          <a:solidFill>
+            <a:srgbClr val="F8FAFC"/>
+          </a:solidFill>
+          <a:ln w="19050">
+            <a:solidFill>
+              <a:srgbClr val="EA580C"/>
+            </a:solidFill>
+          </a:ln>
+        </p:spPr>
+        <p:style>
+          <a:lnRef idx="1">
+            <a:schemeClr val="accent1"/>
+          </a:lnRef>
+          <a:fillRef idx="3">
+            <a:schemeClr val="accent1"/>
+          </a:fillRef>
+          <a:effectRef idx="2">
+            <a:schemeClr val="accent1"/>
+          </a:effectRef>
+          <a:fontRef idx="minor">
+            <a:schemeClr val="lt1"/>
+          </a:fontRef>
+        </p:style>
+        <p:txBody>
+          <a:bodyPr rtlCol="0" anchor="ctr"/>
+          <a:lstStyle/>
+          <a:p>
+            <a:pPr algn="ctr"/>
+          </a:p>
+        </p:txBody>
+      </p:sp>
+      <p:sp>
+        <p:nvSpPr>
+          <p:cNvPr id="13" name="TextBox 12"/>
+          <p:cNvSpPr txBox="1"/>
+          <p:nvPr/>
+        </p:nvSpPr>
+        <p:spPr>
+          <a:xfrm>
+            <a:off x="7379208" y="2057400"/>
+            <a:ext cx="1792224" cy="3566160"/>
+          </a:xfrm>
+          <a:prstGeom prst="rect">
+            <a:avLst/>
+          </a:prstGeom>
+          <a:noFill/>
+        </p:spPr>
+        <p:txBody>
+          <a:bodyPr wrap="square">
+            <a:spAutoFit/>
+          </a:bodyPr>
+          <a:lstStyle/>
+          <a:p>
+            <a:pPr>
+              <a:spcAft>
+                <a:spcPts val="400"/>
+              </a:spcAft>
+              <a:defRPr sz="1300" b="1">
+                <a:solidFill>
+                  <a:srgbClr val="EA580C"/>
+                </a:solidFill>
+                <a:latin typeface="Aptos"/>
+              </a:defRPr>
+            </a:pPr>
+            <a:r>
+              <a:t>BAND</a:t>
+            </a:r>
+          </a:p>
+          <a:p>
+            <a:pPr>
+              <a:spcAft>
+                <a:spcPts val="1200"/>
+              </a:spcAft>
+              <a:defRPr sz="1100" b="1">
+                <a:solidFill>
+                  <a:srgbClr val="0F172A"/>
+                </a:solidFill>
+                <a:latin typeface="Aptos"/>
+              </a:defRPr>
+            </a:pPr>
+            <a:r>
+              <a:t>Human Escalation</a:t>
+            </a:r>
+          </a:p>
+          <a:p>
+            <a:pPr>
+              <a:defRPr sz="1050">
+                <a:solidFill>
+                  <a:srgbClr val="475569"/>
+                </a:solidFill>
+                <a:latin typeface="Aptos"/>
+              </a:defRPr>
+            </a:pPr>
+            <a:r>
+              <a:t>Carries remote human interventions and correlated response events.</a:t>
+            </a:r>
+          </a:p>
+        </p:txBody>
+      </p:sp>
+      <p:sp>
+        <p:nvSpPr>
+          <p:cNvPr id="14" name="Rounded Rectangle 13"/>
+          <p:cNvSpPr/>
+          <p:nvPr/>
+        </p:nvSpPr>
+        <p:spPr>
+          <a:xfrm>
+            <a:off x="9464040" y="1920240"/>
+            <a:ext cx="2011680" cy="3840480"/>
+          </a:xfrm>
+          <a:prstGeom prst="roundRect">
+            <a:avLst/>
+          </a:prstGeom>
+          <a:solidFill>
+            <a:srgbClr val="F8FAFC"/>
+          </a:solidFill>
+          <a:ln w="19050">
+            <a:solidFill>
+              <a:srgbClr val="0F172A"/>
+            </a:solidFill>
+          </a:ln>
+        </p:spPr>
+        <p:style>
+          <a:lnRef idx="1">
+            <a:schemeClr val="accent1"/>
+          </a:lnRef>
+          <a:fillRef idx="3">
+            <a:schemeClr val="accent1"/>
+          </a:fillRef>
+          <a:effectRef idx="2">
+            <a:schemeClr val="accent1"/>
+          </a:effectRef>
+          <a:fontRef idx="minor">
+            <a:schemeClr val="lt1"/>
+          </a:fontRef>
+        </p:style>
+        <p:txBody>
+          <a:bodyPr rtlCol="0" anchor="ctr"/>
+          <a:lstStyle/>
+          <a:p>
+            <a:pPr algn="ctr"/>
+          </a:p>
+        </p:txBody>
+      </p:sp>
+      <p:sp>
+        <p:nvSpPr>
+          <p:cNvPr id="15" name="TextBox 14"/>
+          <p:cNvSpPr txBox="1"/>
+          <p:nvPr/>
+        </p:nvSpPr>
+        <p:spPr>
+          <a:xfrm>
+            <a:off x="9573768" y="2057400"/>
+            <a:ext cx="1792224" cy="3566160"/>
+          </a:xfrm>
+          <a:prstGeom prst="rect">
+            <a:avLst/>
+          </a:prstGeom>
+          <a:noFill/>
+        </p:spPr>
+        <p:txBody>
+          <a:bodyPr wrap="square">
+            <a:spAutoFit/>
+          </a:bodyPr>
+          <a:lstStyle/>
+          <a:p>
+            <a:pPr>
+              <a:spcAft>
+                <a:spcPts val="400"/>
+              </a:spcAft>
+              <a:defRPr sz="1300" b="1">
+                <a:solidFill>
+                  <a:srgbClr val="0F172A"/>
+                </a:solidFill>
+                <a:latin typeface="Aptos"/>
+              </a:defRPr>
+            </a:pPr>
+            <a:r>
+              <a:t>GUILD.AI</a:t>
+            </a:r>
+          </a:p>
+          <a:p>
+            <a:pPr>
+              <a:spcAft>
+                <a:spcPts val="1200"/>
+              </a:spcAft>
+              <a:defRPr sz="1100" b="1">
+                <a:solidFill>
+                  <a:srgbClr val="0F172A"/>
+                </a:solidFill>
+                <a:latin typeface="Aptos"/>
+              </a:defRPr>
+            </a:pPr>
+            <a:r>
+              <a:t>Release Governance</a:t>
+            </a:r>
+          </a:p>
+          <a:p>
+            <a:pPr>
+              <a:defRPr sz="1050">
+                <a:solidFill>
+                  <a:srgbClr val="475569"/>
+                </a:solidFill>
+                <a:latin typeface="Aptos"/>
+              </a:defRPr>
+            </a:pPr>
+            <a:r>
+              <a:t>Publishes and governs active production releases and candidate models.</a:t>
+            </a:r>
+          </a:p>
+        </p:txBody>
+      </p:sp>
+    </p:spTree>
+  </p:cSld>
+  <p:clrMapOvr>
+    <a:masterClrMapping/>
+  </p:clrMapOvr>
+</p:sld>
+</file>
+
 <file path=ppt/theme/theme1.xml><?xml version="1.0" encoding="utf-8"?>
 <a:theme xmlns:a="http://schemas.openxmlformats.org/drawingml/2006/main" name="ChatGPT">
   <a:themeElements>

</xml_diff>

<commit_message>
docs: detail concrete adapter implementations on sponsor slide
</commit_message>
<xml_diff>
--- a/outputs/evox-simple-explainer.pptx
+++ b/outputs/evox-simple-explainer.pptx
@@ -947,32 +947,32 @@
           <a:lstStyle/>
           <a:p>
             <a:r>
-              <a:t>Sponsor Integration Architecture:</a:t>
+              <a:t>Concrete Sponsor Integration Architecture:</a:t>
             </a:r>
           </a:p>
           <a:p>
             <a:r>
-              <a:t>- Pioneer handles model execution fail-closed behind a clean gateway.</a:t>
+              <a:t>- evox_api.adapters.pioneer: PioneerModelGateway handles model execution and health checks.</a:t>
             </a:r>
           </a:p>
           <a:p>
             <a:r>
-              <a:t>- Senso provides indexed documentation and cited context retrieval.</a:t>
+              <a:t>- evox_api.adapters.senso: SensoAdapter ingests docs and retrieves cited evidence for agent steps.</a:t>
             </a:r>
           </a:p>
           <a:p>
             <a:r>
-              <a:t>- Actian VectorAI stores execution trajectories and failure patterns for fast similarity search.</a:t>
+              <a:t>- evox_api.adapters.actian: ActianOutcomeMemorySettings connects to VectorAI for trajectory indexing.</a:t>
             </a:r>
           </a:p>
           <a:p>
             <a:r>
-              <a:t>- Band routes uncertain decisions to real human reviewers.</a:t>
+              <a:t>- evox_api.adapters.band: EscalationConfig &amp; AsyncRestClient dispatch human approval requests.</a:t>
             </a:r>
           </a:p>
           <a:p>
             <a:r>
-              <a:t>- Guild.ai governs active release promotion and system publication.</a:t>
+              <a:t>- evox_api.adapters.guild: GuildSettings verifies agent workspace publication &amp; version governance.</a:t>
             </a:r>
           </a:p>
         </p:txBody>
@@ -6915,7 +6915,7 @@
               </a:defRPr>
             </a:pPr>
             <a:r>
-              <a:t>Every sponsor technology sits behind a production port.</a:t>
+              <a:t>Every sponsor technology is integrated via concrete API adapters.</a:t>
             </a:r>
           </a:p>
         </p:txBody>
@@ -6951,7 +6951,7 @@
               </a:defRPr>
             </a:pPr>
             <a:r>
-              <a:t>Real persisted state and configured integrations power the entire learning loop.</a:t>
+              <a:t>Real persisted state and configured endpoints power every stage of the Evox governance engine.</a:t>
             </a:r>
           </a:p>
         </p:txBody>
@@ -6965,7 +6965,7 @@
         <p:spPr>
           <a:xfrm>
             <a:off x="685800" y="1920240"/>
-            <a:ext cx="2011680" cy="3840480"/>
+            <a:ext cx="2011680" cy="3931920"/>
           </a:xfrm>
           <a:prstGeom prst="roundRect">
             <a:avLst/>
@@ -7009,8 +7009,8 @@
         </p:nvSpPr>
         <p:spPr>
           <a:xfrm>
-            <a:off x="795528" y="2057400"/>
-            <a:ext cx="1792224" cy="3566160"/>
+            <a:off x="777240" y="2029968"/>
+            <a:ext cx="1828800" cy="3712464"/>
           </a:xfrm>
           <a:prstGeom prst="rect">
             <a:avLst/>
@@ -7025,9 +7025,9 @@
           <a:p>
             <a:pPr>
               <a:spcAft>
-                <a:spcPts val="400"/>
+                <a:spcPts val="200"/>
               </a:spcAft>
-              <a:defRPr sz="1300" b="1">
+              <a:defRPr sz="1250" b="1">
                 <a:solidFill>
                   <a:srgbClr val="2563EB"/>
                 </a:solidFill>
@@ -7041,9 +7041,9 @@
           <a:p>
             <a:pPr>
               <a:spcAft>
-                <a:spcPts val="1200"/>
+                <a:spcPts val="200"/>
               </a:spcAft>
-              <a:defRPr sz="1100" b="1">
+              <a:defRPr sz="1050" b="1">
                 <a:solidFill>
                   <a:srgbClr val="0F172A"/>
                 </a:solidFill>
@@ -7051,20 +7051,36 @@
               </a:defRPr>
             </a:pPr>
             <a:r>
-              <a:t>Model Gateway</a:t>
+              <a:t>Model Gateway Adapter</a:t>
             </a:r>
           </a:p>
           <a:p>
             <a:pPr>
-              <a:defRPr sz="1050">
+              <a:spcAft>
+                <a:spcPts val="800"/>
+              </a:spcAft>
+              <a:defRPr sz="850">
                 <a:solidFill>
                   <a:srgbClr val="475569"/>
                 </a:solidFill>
+                <a:latin typeface="Courier New"/>
+              </a:defRPr>
+            </a:pPr>
+            <a:r>
+              <a:t>evox_api.adapters.pioneer</a:t>
+            </a:r>
+          </a:p>
+          <a:p>
+            <a:pPr>
+              <a:defRPr sz="950">
+                <a:solidFill>
+                  <a:srgbClr val="475569"/>
+                </a:solidFill>
                 <a:latin typeface="Aptos"/>
               </a:defRPr>
             </a:pPr>
             <a:r>
-              <a:t>Production gateway for model execution and prompt inference.</a:t>
+              <a:t>Wraps the Pioneer REST gateway. Validates model readiness, routes prompt execution, and enforces fail-closed model resolution.</a:t>
             </a:r>
           </a:p>
         </p:txBody>
@@ -7078,7 +7094,7 @@
         <p:spPr>
           <a:xfrm>
             <a:off x="2880360" y="1920240"/>
-            <a:ext cx="2011680" cy="3840480"/>
+            <a:ext cx="2011680" cy="3931920"/>
           </a:xfrm>
           <a:prstGeom prst="roundRect">
             <a:avLst/>
@@ -7122,8 +7138,8 @@
         </p:nvSpPr>
         <p:spPr>
           <a:xfrm>
-            <a:off x="2990088" y="2057400"/>
-            <a:ext cx="1792224" cy="3566160"/>
+            <a:off x="2971800" y="2029968"/>
+            <a:ext cx="1828800" cy="3712464"/>
           </a:xfrm>
           <a:prstGeom prst="rect">
             <a:avLst/>
@@ -7138,9 +7154,9 @@
           <a:p>
             <a:pPr>
               <a:spcAft>
-                <a:spcPts val="400"/>
+                <a:spcPts val="200"/>
               </a:spcAft>
-              <a:defRPr sz="1300" b="1">
+              <a:defRPr sz="1250" b="1">
                 <a:solidFill>
                   <a:srgbClr val="9333EA"/>
                 </a:solidFill>
@@ -7154,9 +7170,9 @@
           <a:p>
             <a:pPr>
               <a:spcAft>
-                <a:spcPts val="1200"/>
+                <a:spcPts val="200"/>
               </a:spcAft>
-              <a:defRPr sz="1100" b="1">
+              <a:defRPr sz="1050" b="1">
                 <a:solidFill>
                   <a:srgbClr val="0F172A"/>
                 </a:solidFill>
@@ -7164,20 +7180,36 @@
               </a:defRPr>
             </a:pPr>
             <a:r>
-              <a:t>Knowledge Layer</a:t>
+              <a:t>Cited Document Context</a:t>
             </a:r>
           </a:p>
           <a:p>
             <a:pPr>
-              <a:defRPr sz="1050">
+              <a:spcAft>
+                <a:spcPts val="800"/>
+              </a:spcAft>
+              <a:defRPr sz="850">
                 <a:solidFill>
                   <a:srgbClr val="475569"/>
                 </a:solidFill>
+                <a:latin typeface="Courier New"/>
+              </a:defRPr>
+            </a:pPr>
+            <a:r>
+              <a:t>evox_api.adapters.senso</a:t>
+            </a:r>
+          </a:p>
+          <a:p>
+            <a:pPr>
+              <a:defRPr sz="950">
+                <a:solidFill>
+                  <a:srgbClr val="475569"/>
+                </a:solidFill>
                 <a:latin typeface="Aptos"/>
               </a:defRPr>
             </a:pPr>
             <a:r>
-              <a:t>Ingests documentation and provides cited context retrieval.</a:t>
+              <a:t>Connects to Senso org API to ingest corpus documents and retrieve exact cited text snippets for agent reasoning.</a:t>
             </a:r>
           </a:p>
         </p:txBody>
@@ -7191,7 +7223,7 @@
         <p:spPr>
           <a:xfrm>
             <a:off x="5074920" y="1920240"/>
-            <a:ext cx="2011680" cy="3840480"/>
+            <a:ext cx="2011680" cy="3931920"/>
           </a:xfrm>
           <a:prstGeom prst="roundRect">
             <a:avLst/>
@@ -7235,8 +7267,8 @@
         </p:nvSpPr>
         <p:spPr>
           <a:xfrm>
-            <a:off x="5184648" y="2057400"/>
-            <a:ext cx="1792224" cy="3566160"/>
+            <a:off x="5166360" y="2029968"/>
+            <a:ext cx="1828800" cy="3712464"/>
           </a:xfrm>
           <a:prstGeom prst="rect">
             <a:avLst/>
@@ -7251,9 +7283,9 @@
           <a:p>
             <a:pPr>
               <a:spcAft>
-                <a:spcPts val="400"/>
+                <a:spcPts val="200"/>
               </a:spcAft>
-              <a:defRPr sz="1300" b="1">
+              <a:defRPr sz="1250" b="1">
                 <a:solidFill>
                   <a:srgbClr val="16A34A"/>
                 </a:solidFill>
@@ -7267,9 +7299,9 @@
           <a:p>
             <a:pPr>
               <a:spcAft>
-                <a:spcPts val="1200"/>
+                <a:spcPts val="200"/>
               </a:spcAft>
-              <a:defRPr sz="1100" b="1">
+              <a:defRPr sz="1050" b="1">
                 <a:solidFill>
                   <a:srgbClr val="0F172A"/>
                 </a:solidFill>
@@ -7277,20 +7309,36 @@
               </a:defRPr>
             </a:pPr>
             <a:r>
-              <a:t>Outcome Memory</a:t>
+              <a:t>Outcome Memory Store</a:t>
             </a:r>
           </a:p>
           <a:p>
             <a:pPr>
-              <a:defRPr sz="1050">
+              <a:spcAft>
+                <a:spcPts val="800"/>
+              </a:spcAft>
+              <a:defRPr sz="850">
                 <a:solidFill>
                   <a:srgbClr val="475569"/>
                 </a:solidFill>
+                <a:latin typeface="Courier New"/>
+              </a:defRPr>
+            </a:pPr>
+            <a:r>
+              <a:t>evox_api.adapters.actian</a:t>
+            </a:r>
+          </a:p>
+          <a:p>
+            <a:pPr>
+              <a:defRPr sz="950">
+                <a:solidFill>
+                  <a:srgbClr val="475569"/>
+                </a:solidFill>
                 <a:latin typeface="Aptos"/>
               </a:defRPr>
             </a:pPr>
             <a:r>
-              <a:t>Stores searchable run outcomes, trajectories, and failure patterns.</a:t>
+              <a:t>Connects to Actian VectorAI vector DB to index run trajectories and query past failure/success patterns.</a:t>
             </a:r>
           </a:p>
         </p:txBody>
@@ -7304,7 +7352,7 @@
         <p:spPr>
           <a:xfrm>
             <a:off x="7269480" y="1920240"/>
-            <a:ext cx="2011680" cy="3840480"/>
+            <a:ext cx="2011680" cy="3931920"/>
           </a:xfrm>
           <a:prstGeom prst="roundRect">
             <a:avLst/>
@@ -7348,8 +7396,8 @@
         </p:nvSpPr>
         <p:spPr>
           <a:xfrm>
-            <a:off x="7379208" y="2057400"/>
-            <a:ext cx="1792224" cy="3566160"/>
+            <a:off x="7360920" y="2029968"/>
+            <a:ext cx="1828800" cy="3712464"/>
           </a:xfrm>
           <a:prstGeom prst="rect">
             <a:avLst/>
@@ -7364,9 +7412,9 @@
           <a:p>
             <a:pPr>
               <a:spcAft>
-                <a:spcPts val="400"/>
+                <a:spcPts val="200"/>
               </a:spcAft>
-              <a:defRPr sz="1300" b="1">
+              <a:defRPr sz="1250" b="1">
                 <a:solidFill>
                   <a:srgbClr val="EA580C"/>
                 </a:solidFill>
@@ -7380,9 +7428,9 @@
           <a:p>
             <a:pPr>
               <a:spcAft>
-                <a:spcPts val="1200"/>
+                <a:spcPts val="200"/>
               </a:spcAft>
-              <a:defRPr sz="1100" b="1">
+              <a:defRPr sz="1050" b="1">
                 <a:solidFill>
                   <a:srgbClr val="0F172A"/>
                 </a:solidFill>
@@ -7390,20 +7438,36 @@
               </a:defRPr>
             </a:pPr>
             <a:r>
-              <a:t>Human Escalation</a:t>
+              <a:t>Human Escalation Bridge</a:t>
             </a:r>
           </a:p>
           <a:p>
             <a:pPr>
-              <a:defRPr sz="1050">
+              <a:spcAft>
+                <a:spcPts val="800"/>
+              </a:spcAft>
+              <a:defRPr sz="850">
                 <a:solidFill>
                   <a:srgbClr val="475569"/>
                 </a:solidFill>
+                <a:latin typeface="Courier New"/>
+              </a:defRPr>
+            </a:pPr>
+            <a:r>
+              <a:t>evox_api.adapters.band</a:t>
+            </a:r>
+          </a:p>
+          <a:p>
+            <a:pPr>
+              <a:defRPr sz="950">
+                <a:solidFill>
+                  <a:srgbClr val="475569"/>
+                </a:solidFill>
                 <a:latin typeface="Aptos"/>
               </a:defRPr>
             </a:pPr>
             <a:r>
-              <a:t>Carries remote human interventions and correlated response events.</a:t>
+              <a:t>Uses Band AsyncRestClient to create escalation tasks, poll worker feedback, and deliver human decisions back into jobs.</a:t>
             </a:r>
           </a:p>
         </p:txBody>
@@ -7417,7 +7481,7 @@
         <p:spPr>
           <a:xfrm>
             <a:off x="9464040" y="1920240"/>
-            <a:ext cx="2011680" cy="3840480"/>
+            <a:ext cx="2011680" cy="3931920"/>
           </a:xfrm>
           <a:prstGeom prst="roundRect">
             <a:avLst/>
@@ -7461,8 +7525,8 @@
         </p:nvSpPr>
         <p:spPr>
           <a:xfrm>
-            <a:off x="9573768" y="2057400"/>
-            <a:ext cx="1792224" cy="3566160"/>
+            <a:off x="9555480" y="2029968"/>
+            <a:ext cx="1828800" cy="3712464"/>
           </a:xfrm>
           <a:prstGeom prst="rect">
             <a:avLst/>
@@ -7477,9 +7541,9 @@
           <a:p>
             <a:pPr>
               <a:spcAft>
-                <a:spcPts val="400"/>
+                <a:spcPts val="200"/>
               </a:spcAft>
-              <a:defRPr sz="1300" b="1">
+              <a:defRPr sz="1250" b="1">
                 <a:solidFill>
                   <a:srgbClr val="0F172A"/>
                 </a:solidFill>
@@ -7493,9 +7557,9 @@
           <a:p>
             <a:pPr>
               <a:spcAft>
-                <a:spcPts val="1200"/>
+                <a:spcPts val="200"/>
               </a:spcAft>
-              <a:defRPr sz="1100" b="1">
+              <a:defRPr sz="1050" b="1">
                 <a:solidFill>
                   <a:srgbClr val="0F172A"/>
                 </a:solidFill>
@@ -7503,20 +7567,36 @@
               </a:defRPr>
             </a:pPr>
             <a:r>
-              <a:t>Release Governance</a:t>
+              <a:t>Release Publisher</a:t>
             </a:r>
           </a:p>
           <a:p>
             <a:pPr>
-              <a:defRPr sz="1050">
+              <a:spcAft>
+                <a:spcPts val="800"/>
+              </a:spcAft>
+              <a:defRPr sz="850">
                 <a:solidFill>
                   <a:srgbClr val="475569"/>
                 </a:solidFill>
+                <a:latin typeface="Courier New"/>
+              </a:defRPr>
+            </a:pPr>
+            <a:r>
+              <a:t>evox_api.adapters.guild</a:t>
+            </a:r>
+          </a:p>
+          <a:p>
+            <a:pPr>
+              <a:defRPr sz="950">
+                <a:solidFill>
+                  <a:srgbClr val="475569"/>
+                </a:solidFill>
                 <a:latin typeface="Aptos"/>
               </a:defRPr>
             </a:pPr>
             <a:r>
-              <a:t>Publishes and governs active production releases and candidate models.</a:t>
+              <a:t>Publishes proven candidate workflows to Guild.ai workspace, locking active release versions and evaluator rules.</a:t>
             </a:r>
           </a:p>
         </p:txBody>

</xml_diff>